<commit_message>
Updates for Dan's talks
</commit_message>
<xml_diff>
--- a/Daniel Messer/Thousands of Tables and Four Farthings/1000s of Tables and 4 Farthings.pptx
+++ b/Daniel Messer/Thousands of Tables and Four Farthings/1000s of Tables and 4 Farthings.pptx
@@ -216,7 +216,7 @@
           <a:p>
             <a:fld id="{745E792A-D199-4740-A380-51F76153B224}" type="datetimeFigureOut">
               <a:rPr lang="en-US" smtClean="0"/>
-              <a:t>4/5/26</a:t>
+              <a:t>4/6/26</a:t>
             </a:fld>
             <a:endParaRPr lang="en-US"/>
           </a:p>
@@ -2658,7 +2658,7 @@
           <a:p>
             <a:fld id="{30B7B0CA-7F1D-7440-BF86-78A318A6FD35}" type="datetimeFigureOut">
               <a:rPr lang="en-US" smtClean="0"/>
-              <a:t>4/5/26</a:t>
+              <a:t>4/6/26</a:t>
             </a:fld>
             <a:endParaRPr lang="en-US"/>
           </a:p>
@@ -2856,7 +2856,7 @@
           <a:p>
             <a:fld id="{30B7B0CA-7F1D-7440-BF86-78A318A6FD35}" type="datetimeFigureOut">
               <a:rPr lang="en-US" smtClean="0"/>
-              <a:t>4/5/26</a:t>
+              <a:t>4/6/26</a:t>
             </a:fld>
             <a:endParaRPr lang="en-US"/>
           </a:p>
@@ -3064,7 +3064,7 @@
           <a:p>
             <a:fld id="{30B7B0CA-7F1D-7440-BF86-78A318A6FD35}" type="datetimeFigureOut">
               <a:rPr lang="en-US" smtClean="0"/>
-              <a:t>4/5/26</a:t>
+              <a:t>4/6/26</a:t>
             </a:fld>
             <a:endParaRPr lang="en-US"/>
           </a:p>
@@ -3262,7 +3262,7 @@
           <a:p>
             <a:fld id="{30B7B0CA-7F1D-7440-BF86-78A318A6FD35}" type="datetimeFigureOut">
               <a:rPr lang="en-US" smtClean="0"/>
-              <a:t>4/5/26</a:t>
+              <a:t>4/6/26</a:t>
             </a:fld>
             <a:endParaRPr lang="en-US"/>
           </a:p>
@@ -3537,7 +3537,7 @@
           <a:p>
             <a:fld id="{30B7B0CA-7F1D-7440-BF86-78A318A6FD35}" type="datetimeFigureOut">
               <a:rPr lang="en-US" smtClean="0"/>
-              <a:t>4/5/26</a:t>
+              <a:t>4/6/26</a:t>
             </a:fld>
             <a:endParaRPr lang="en-US"/>
           </a:p>
@@ -3802,7 +3802,7 @@
           <a:p>
             <a:fld id="{30B7B0CA-7F1D-7440-BF86-78A318A6FD35}" type="datetimeFigureOut">
               <a:rPr lang="en-US" smtClean="0"/>
-              <a:t>4/5/26</a:t>
+              <a:t>4/6/26</a:t>
             </a:fld>
             <a:endParaRPr lang="en-US"/>
           </a:p>
@@ -4214,7 +4214,7 @@
           <a:p>
             <a:fld id="{30B7B0CA-7F1D-7440-BF86-78A318A6FD35}" type="datetimeFigureOut">
               <a:rPr lang="en-US" smtClean="0"/>
-              <a:t>4/5/26</a:t>
+              <a:t>4/6/26</a:t>
             </a:fld>
             <a:endParaRPr lang="en-US"/>
           </a:p>
@@ -4355,7 +4355,7 @@
           <a:p>
             <a:fld id="{30B7B0CA-7F1D-7440-BF86-78A318A6FD35}" type="datetimeFigureOut">
               <a:rPr lang="en-US" smtClean="0"/>
-              <a:t>4/5/26</a:t>
+              <a:t>4/6/26</a:t>
             </a:fld>
             <a:endParaRPr lang="en-US"/>
           </a:p>
@@ -4468,7 +4468,7 @@
           <a:p>
             <a:fld id="{30B7B0CA-7F1D-7440-BF86-78A318A6FD35}" type="datetimeFigureOut">
               <a:rPr lang="en-US" smtClean="0"/>
-              <a:t>4/5/26</a:t>
+              <a:t>4/6/26</a:t>
             </a:fld>
             <a:endParaRPr lang="en-US"/>
           </a:p>
@@ -4779,7 +4779,7 @@
           <a:p>
             <a:fld id="{30B7B0CA-7F1D-7440-BF86-78A318A6FD35}" type="datetimeFigureOut">
               <a:rPr lang="en-US" smtClean="0"/>
-              <a:t>4/5/26</a:t>
+              <a:t>4/6/26</a:t>
             </a:fld>
             <a:endParaRPr lang="en-US"/>
           </a:p>
@@ -5070,7 +5070,7 @@
           <a:p>
             <a:fld id="{30B7B0CA-7F1D-7440-BF86-78A318A6FD35}" type="datetimeFigureOut">
               <a:rPr lang="en-US" smtClean="0"/>
-              <a:t>4/5/26</a:t>
+              <a:t>4/6/26</a:t>
             </a:fld>
             <a:endParaRPr lang="en-US"/>
           </a:p>
@@ -5311,7 +5311,7 @@
           <a:p>
             <a:fld id="{30B7B0CA-7F1D-7440-BF86-78A318A6FD35}" type="datetimeFigureOut">
               <a:rPr lang="en-US" smtClean="0"/>
-              <a:t>4/5/26</a:t>
+              <a:t>4/6/26</a:t>
             </a:fld>
             <a:endParaRPr lang="en-US"/>
           </a:p>
@@ -6611,15 +6611,33 @@
                                   </p:childTnLst>
                                 </p:cTn>
                               </p:par>
+                            </p:childTnLst>
+                          </p:cTn>
+                        </p:par>
+                      </p:childTnLst>
+                    </p:cTn>
+                  </p:par>
+                  <p:par>
+                    <p:cTn id="7" fill="hold">
+                      <p:stCondLst>
+                        <p:cond delay="indefinite"/>
+                      </p:stCondLst>
+                      <p:childTnLst>
+                        <p:par>
+                          <p:cTn id="8" fill="hold">
+                            <p:stCondLst>
+                              <p:cond delay="0"/>
+                            </p:stCondLst>
+                            <p:childTnLst>
                               <p:par>
-                                <p:cTn id="7" presetID="1" presetClass="entr" presetSubtype="0" fill="hold" grpId="0" nodeType="withEffect">
+                                <p:cTn id="9" presetID="1" presetClass="entr" presetSubtype="0" fill="hold" grpId="0" nodeType="clickEffect">
                                   <p:stCondLst>
                                     <p:cond delay="0"/>
                                   </p:stCondLst>
                                   <p:childTnLst>
                                     <p:set>
                                       <p:cBhvr>
-                                        <p:cTn id="8" dur="1" fill="hold">
+                                        <p:cTn id="10" dur="1" fill="hold">
                                           <p:stCondLst>
                                             <p:cond delay="0"/>
                                           </p:stCondLst>
@@ -7217,18 +7235,8 @@
                   <a:schemeClr val="bg1"/>
                 </a:solidFill>
               </a:rPr>
-              <a:t>So let’s do a SQL Trace</a:t>
-            </a:r>
-          </a:p>
-          <a:p>
-            <a:pPr marL="0" indent="0">
-              <a:buNone/>
-            </a:pPr>
-            <a:endParaRPr lang="en-US" dirty="0">
-              <a:solidFill>
-                <a:schemeClr val="bg1"/>
-              </a:solidFill>
-            </a:endParaRPr>
+              <a:t>So let’s trace the call</a:t>
+            </a:r>
           </a:p>
           <a:p>
             <a:endParaRPr lang="en-US" dirty="0">
@@ -7316,15 +7324,33 @@
                                   </p:childTnLst>
                                 </p:cTn>
                               </p:par>
+                            </p:childTnLst>
+                          </p:cTn>
+                        </p:par>
+                      </p:childTnLst>
+                    </p:cTn>
+                  </p:par>
+                  <p:par>
+                    <p:cTn id="7" fill="hold">
+                      <p:stCondLst>
+                        <p:cond delay="indefinite"/>
+                      </p:stCondLst>
+                      <p:childTnLst>
+                        <p:par>
+                          <p:cTn id="8" fill="hold">
+                            <p:stCondLst>
+                              <p:cond delay="0"/>
+                            </p:stCondLst>
+                            <p:childTnLst>
                               <p:par>
-                                <p:cTn id="7" presetID="1" presetClass="entr" presetSubtype="0" fill="hold" grpId="0" nodeType="withEffect">
+                                <p:cTn id="9" presetID="1" presetClass="entr" presetSubtype="0" fill="hold" grpId="0" nodeType="clickEffect">
                                   <p:stCondLst>
                                     <p:cond delay="0"/>
                                   </p:stCondLst>
                                   <p:childTnLst>
                                     <p:set>
                                       <p:cBhvr>
-                                        <p:cTn id="8" dur="1" fill="hold">
+                                        <p:cTn id="10" dur="1" fill="hold">
                                           <p:stCondLst>
                                             <p:cond delay="0"/>
                                           </p:stCondLst>
@@ -7942,15 +7968,33 @@
                                   </p:childTnLst>
                                 </p:cTn>
                               </p:par>
+                            </p:childTnLst>
+                          </p:cTn>
+                        </p:par>
+                      </p:childTnLst>
+                    </p:cTn>
+                  </p:par>
+                  <p:par>
+                    <p:cTn id="11" fill="hold">
+                      <p:stCondLst>
+                        <p:cond delay="indefinite"/>
+                      </p:stCondLst>
+                      <p:childTnLst>
+                        <p:par>
+                          <p:cTn id="12" fill="hold">
+                            <p:stCondLst>
+                              <p:cond delay="0"/>
+                            </p:stCondLst>
+                            <p:childTnLst>
                               <p:par>
-                                <p:cTn id="11" presetID="1" presetClass="entr" presetSubtype="0" fill="hold" grpId="0" nodeType="withEffect">
+                                <p:cTn id="13" presetID="1" presetClass="entr" presetSubtype="0" fill="hold" grpId="0" nodeType="clickEffect">
                                   <p:stCondLst>
                                     <p:cond delay="0"/>
                                   </p:stCondLst>
                                   <p:childTnLst>
                                     <p:set>
                                       <p:cBhvr>
-                                        <p:cTn id="12" dur="1" fill="hold">
+                                        <p:cTn id="14" dur="1" fill="hold">
                                           <p:stCondLst>
                                             <p:cond delay="0"/>
                                           </p:stCondLst>
@@ -7973,15 +8017,33 @@
                                   </p:childTnLst>
                                 </p:cTn>
                               </p:par>
+                            </p:childTnLst>
+                          </p:cTn>
+                        </p:par>
+                      </p:childTnLst>
+                    </p:cTn>
+                  </p:par>
+                  <p:par>
+                    <p:cTn id="15" fill="hold">
+                      <p:stCondLst>
+                        <p:cond delay="indefinite"/>
+                      </p:stCondLst>
+                      <p:childTnLst>
+                        <p:par>
+                          <p:cTn id="16" fill="hold">
+                            <p:stCondLst>
+                              <p:cond delay="0"/>
+                            </p:stCondLst>
+                            <p:childTnLst>
                               <p:par>
-                                <p:cTn id="13" presetID="1" presetClass="entr" presetSubtype="0" fill="hold" grpId="0" nodeType="withEffect">
+                                <p:cTn id="17" presetID="1" presetClass="entr" presetSubtype="0" fill="hold" grpId="0" nodeType="clickEffect">
                                   <p:stCondLst>
                                     <p:cond delay="0"/>
                                   </p:stCondLst>
                                   <p:childTnLst>
                                     <p:set>
                                       <p:cBhvr>
-                                        <p:cTn id="14" dur="1" fill="hold">
+                                        <p:cTn id="18" dur="1" fill="hold">
                                           <p:stCondLst>
                                             <p:cond delay="0"/>
                                           </p:stCondLst>
@@ -8004,15 +8066,33 @@
                                   </p:childTnLst>
                                 </p:cTn>
                               </p:par>
+                            </p:childTnLst>
+                          </p:cTn>
+                        </p:par>
+                      </p:childTnLst>
+                    </p:cTn>
+                  </p:par>
+                  <p:par>
+                    <p:cTn id="19" fill="hold">
+                      <p:stCondLst>
+                        <p:cond delay="indefinite"/>
+                      </p:stCondLst>
+                      <p:childTnLst>
+                        <p:par>
+                          <p:cTn id="20" fill="hold">
+                            <p:stCondLst>
+                              <p:cond delay="0"/>
+                            </p:stCondLst>
+                            <p:childTnLst>
                               <p:par>
-                                <p:cTn id="15" presetID="1" presetClass="entr" presetSubtype="0" fill="hold" grpId="0" nodeType="withEffect">
+                                <p:cTn id="21" presetID="1" presetClass="entr" presetSubtype="0" fill="hold" grpId="0" nodeType="clickEffect">
                                   <p:stCondLst>
                                     <p:cond delay="0"/>
                                   </p:stCondLst>
                                   <p:childTnLst>
                                     <p:set>
                                       <p:cBhvr>
-                                        <p:cTn id="16" dur="1" fill="hold">
+                                        <p:cTn id="22" dur="1" fill="hold">
                                           <p:stCondLst>
                                             <p:cond delay="0"/>
                                           </p:stCondLst>
@@ -8035,15 +8115,33 @@
                                   </p:childTnLst>
                                 </p:cTn>
                               </p:par>
+                            </p:childTnLst>
+                          </p:cTn>
+                        </p:par>
+                      </p:childTnLst>
+                    </p:cTn>
+                  </p:par>
+                  <p:par>
+                    <p:cTn id="23" fill="hold">
+                      <p:stCondLst>
+                        <p:cond delay="indefinite"/>
+                      </p:stCondLst>
+                      <p:childTnLst>
+                        <p:par>
+                          <p:cTn id="24" fill="hold">
+                            <p:stCondLst>
+                              <p:cond delay="0"/>
+                            </p:stCondLst>
+                            <p:childTnLst>
                               <p:par>
-                                <p:cTn id="17" presetID="1" presetClass="entr" presetSubtype="0" fill="hold" grpId="0" nodeType="withEffect">
+                                <p:cTn id="25" presetID="1" presetClass="entr" presetSubtype="0" fill="hold" grpId="0" nodeType="clickEffect">
                                   <p:stCondLst>
                                     <p:cond delay="0"/>
                                   </p:stCondLst>
                                   <p:childTnLst>
                                     <p:set>
                                       <p:cBhvr>
-                                        <p:cTn id="18" dur="1" fill="hold">
+                                        <p:cTn id="26" dur="1" fill="hold">
                                           <p:stCondLst>
                                             <p:cond delay="0"/>
                                           </p:stCondLst>
@@ -8066,15 +8164,33 @@
                                   </p:childTnLst>
                                 </p:cTn>
                               </p:par>
+                            </p:childTnLst>
+                          </p:cTn>
+                        </p:par>
+                      </p:childTnLst>
+                    </p:cTn>
+                  </p:par>
+                  <p:par>
+                    <p:cTn id="27" fill="hold">
+                      <p:stCondLst>
+                        <p:cond delay="indefinite"/>
+                      </p:stCondLst>
+                      <p:childTnLst>
+                        <p:par>
+                          <p:cTn id="28" fill="hold">
+                            <p:stCondLst>
+                              <p:cond delay="0"/>
+                            </p:stCondLst>
+                            <p:childTnLst>
                               <p:par>
-                                <p:cTn id="19" presetID="1" presetClass="entr" presetSubtype="0" fill="hold" grpId="0" nodeType="withEffect">
+                                <p:cTn id="29" presetID="1" presetClass="entr" presetSubtype="0" fill="hold" grpId="0" nodeType="clickEffect">
                                   <p:stCondLst>
                                     <p:cond delay="0"/>
                                   </p:stCondLst>
                                   <p:childTnLst>
                                     <p:set>
                                       <p:cBhvr>
-                                        <p:cTn id="20" dur="1" fill="hold">
+                                        <p:cTn id="30" dur="1" fill="hold">
                                           <p:stCondLst>
                                             <p:cond delay="0"/>
                                           </p:stCondLst>
@@ -8097,15 +8213,33 @@
                                   </p:childTnLst>
                                 </p:cTn>
                               </p:par>
+                            </p:childTnLst>
+                          </p:cTn>
+                        </p:par>
+                      </p:childTnLst>
+                    </p:cTn>
+                  </p:par>
+                  <p:par>
+                    <p:cTn id="31" fill="hold">
+                      <p:stCondLst>
+                        <p:cond delay="indefinite"/>
+                      </p:stCondLst>
+                      <p:childTnLst>
+                        <p:par>
+                          <p:cTn id="32" fill="hold">
+                            <p:stCondLst>
+                              <p:cond delay="0"/>
+                            </p:stCondLst>
+                            <p:childTnLst>
                               <p:par>
-                                <p:cTn id="21" presetID="1" presetClass="entr" presetSubtype="0" fill="hold" grpId="0" nodeType="withEffect">
+                                <p:cTn id="33" presetID="1" presetClass="entr" presetSubtype="0" fill="hold" grpId="0" nodeType="clickEffect">
                                   <p:stCondLst>
                                     <p:cond delay="0"/>
                                   </p:stCondLst>
                                   <p:childTnLst>
                                     <p:set>
                                       <p:cBhvr>
-                                        <p:cTn id="22" dur="1" fill="hold">
+                                        <p:cTn id="34" dur="1" fill="hold">
                                           <p:stCondLst>
                                             <p:cond delay="0"/>
                                           </p:stCondLst>
@@ -11498,7 +11632,7 @@
                   <a:srgbClr val="82DCF1"/>
                 </a:solidFill>
               </a:rPr>
-              <a:t>Got the Process, Hack the Process</a:t>
+              <a:t>Know the Process, Hack the Process</a:t>
             </a:r>
           </a:p>
         </p:txBody>
@@ -12003,15 +12137,33 @@
                                   </p:childTnLst>
                                 </p:cTn>
                               </p:par>
+                            </p:childTnLst>
+                          </p:cTn>
+                        </p:par>
+                      </p:childTnLst>
+                    </p:cTn>
+                  </p:par>
+                  <p:par>
+                    <p:cTn id="7" fill="hold">
+                      <p:stCondLst>
+                        <p:cond delay="indefinite"/>
+                      </p:stCondLst>
+                      <p:childTnLst>
+                        <p:par>
+                          <p:cTn id="8" fill="hold">
+                            <p:stCondLst>
+                              <p:cond delay="0"/>
+                            </p:stCondLst>
+                            <p:childTnLst>
                               <p:par>
-                                <p:cTn id="7" presetID="1" presetClass="entr" presetSubtype="0" fill="hold" grpId="0" nodeType="withEffect">
+                                <p:cTn id="9" presetID="1" presetClass="entr" presetSubtype="0" fill="hold" grpId="0" nodeType="clickEffect">
                                   <p:stCondLst>
                                     <p:cond delay="0"/>
                                   </p:stCondLst>
                                   <p:childTnLst>
                                     <p:set>
                                       <p:cBhvr>
-                                        <p:cTn id="8" dur="1" fill="hold">
+                                        <p:cTn id="10" dur="1" fill="hold">
                                           <p:stCondLst>
                                             <p:cond delay="0"/>
                                           </p:stCondLst>
@@ -12034,15 +12186,33 @@
                                   </p:childTnLst>
                                 </p:cTn>
                               </p:par>
+                            </p:childTnLst>
+                          </p:cTn>
+                        </p:par>
+                      </p:childTnLst>
+                    </p:cTn>
+                  </p:par>
+                  <p:par>
+                    <p:cTn id="11" fill="hold">
+                      <p:stCondLst>
+                        <p:cond delay="indefinite"/>
+                      </p:stCondLst>
+                      <p:childTnLst>
+                        <p:par>
+                          <p:cTn id="12" fill="hold">
+                            <p:stCondLst>
+                              <p:cond delay="0"/>
+                            </p:stCondLst>
+                            <p:childTnLst>
                               <p:par>
-                                <p:cTn id="9" presetID="1" presetClass="entr" presetSubtype="0" fill="hold" grpId="0" nodeType="withEffect">
+                                <p:cTn id="13" presetID="1" presetClass="entr" presetSubtype="0" fill="hold" grpId="0" nodeType="clickEffect">
                                   <p:stCondLst>
                                     <p:cond delay="0"/>
                                   </p:stCondLst>
                                   <p:childTnLst>
                                     <p:set>
                                       <p:cBhvr>
-                                        <p:cTn id="10" dur="1" fill="hold">
+                                        <p:cTn id="14" dur="1" fill="hold">
                                           <p:stCondLst>
                                             <p:cond delay="0"/>
                                           </p:stCondLst>
@@ -12065,15 +12235,33 @@
                                   </p:childTnLst>
                                 </p:cTn>
                               </p:par>
+                            </p:childTnLst>
+                          </p:cTn>
+                        </p:par>
+                      </p:childTnLst>
+                    </p:cTn>
+                  </p:par>
+                  <p:par>
+                    <p:cTn id="15" fill="hold">
+                      <p:stCondLst>
+                        <p:cond delay="indefinite"/>
+                      </p:stCondLst>
+                      <p:childTnLst>
+                        <p:par>
+                          <p:cTn id="16" fill="hold">
+                            <p:stCondLst>
+                              <p:cond delay="0"/>
+                            </p:stCondLst>
+                            <p:childTnLst>
                               <p:par>
-                                <p:cTn id="11" presetID="1" presetClass="entr" presetSubtype="0" fill="hold" grpId="0" nodeType="withEffect">
+                                <p:cTn id="17" presetID="1" presetClass="entr" presetSubtype="0" fill="hold" grpId="0" nodeType="clickEffect">
                                   <p:stCondLst>
                                     <p:cond delay="0"/>
                                   </p:stCondLst>
                                   <p:childTnLst>
                                     <p:set>
                                       <p:cBhvr>
-                                        <p:cTn id="12" dur="1" fill="hold">
+                                        <p:cTn id="18" dur="1" fill="hold">
                                           <p:stCondLst>
                                             <p:cond delay="0"/>
                                           </p:stCondLst>
@@ -12096,15 +12284,33 @@
                                   </p:childTnLst>
                                 </p:cTn>
                               </p:par>
+                            </p:childTnLst>
+                          </p:cTn>
+                        </p:par>
+                      </p:childTnLst>
+                    </p:cTn>
+                  </p:par>
+                  <p:par>
+                    <p:cTn id="19" fill="hold">
+                      <p:stCondLst>
+                        <p:cond delay="indefinite"/>
+                      </p:stCondLst>
+                      <p:childTnLst>
+                        <p:par>
+                          <p:cTn id="20" fill="hold">
+                            <p:stCondLst>
+                              <p:cond delay="0"/>
+                            </p:stCondLst>
+                            <p:childTnLst>
                               <p:par>
-                                <p:cTn id="13" presetID="1" presetClass="entr" presetSubtype="0" fill="hold" grpId="0" nodeType="withEffect">
+                                <p:cTn id="21" presetID="1" presetClass="entr" presetSubtype="0" fill="hold" grpId="0" nodeType="clickEffect">
                                   <p:stCondLst>
                                     <p:cond delay="0"/>
                                   </p:stCondLst>
                                   <p:childTnLst>
                                     <p:set>
                                       <p:cBhvr>
-                                        <p:cTn id="14" dur="1" fill="hold">
+                                        <p:cTn id="22" dur="1" fill="hold">
                                           <p:stCondLst>
                                             <p:cond delay="0"/>
                                           </p:stCondLst>
@@ -12127,15 +12333,33 @@
                                   </p:childTnLst>
                                 </p:cTn>
                               </p:par>
+                            </p:childTnLst>
+                          </p:cTn>
+                        </p:par>
+                      </p:childTnLst>
+                    </p:cTn>
+                  </p:par>
+                  <p:par>
+                    <p:cTn id="23" fill="hold">
+                      <p:stCondLst>
+                        <p:cond delay="indefinite"/>
+                      </p:stCondLst>
+                      <p:childTnLst>
+                        <p:par>
+                          <p:cTn id="24" fill="hold">
+                            <p:stCondLst>
+                              <p:cond delay="0"/>
+                            </p:stCondLst>
+                            <p:childTnLst>
                               <p:par>
-                                <p:cTn id="15" presetID="1" presetClass="entr" presetSubtype="0" fill="hold" grpId="0" nodeType="withEffect">
+                                <p:cTn id="25" presetID="1" presetClass="entr" presetSubtype="0" fill="hold" grpId="0" nodeType="clickEffect">
                                   <p:stCondLst>
                                     <p:cond delay="0"/>
                                   </p:stCondLst>
                                   <p:childTnLst>
                                     <p:set>
                                       <p:cBhvr>
-                                        <p:cTn id="16" dur="1" fill="hold">
+                                        <p:cTn id="26" dur="1" fill="hold">
                                           <p:stCondLst>
                                             <p:cond delay="0"/>
                                           </p:stCondLst>
@@ -13886,6 +14110,38 @@
           </a:p>
         </p:txBody>
       </p:sp>
+      <p:sp>
+        <p:nvSpPr>
+          <p:cNvPr id="2" name="TextBox 1">
+            <a:extLst>
+              <a:ext uri="{FF2B5EF4-FFF2-40B4-BE49-F238E27FC236}">
+                <a16:creationId xmlns:a16="http://schemas.microsoft.com/office/drawing/2014/main" id="{6707CB77-26AC-729A-601E-CB40B7210361}"/>
+              </a:ext>
+            </a:extLst>
+          </p:cNvPr>
+          <p:cNvSpPr txBox="1"/>
+          <p:nvPr/>
+        </p:nvSpPr>
+        <p:spPr>
+          <a:xfrm>
+            <a:off x="680484" y="1998921"/>
+            <a:ext cx="184731" cy="369332"/>
+          </a:xfrm>
+          <a:prstGeom prst="rect">
+            <a:avLst/>
+          </a:prstGeom>
+          <a:noFill/>
+        </p:spPr>
+        <p:txBody>
+          <a:bodyPr wrap="none" rtlCol="0">
+            <a:spAutoFit/>
+          </a:bodyPr>
+          <a:lstStyle/>
+          <a:p>
+            <a:endParaRPr lang="en-US"/>
+          </a:p>
+        </p:txBody>
+      </p:sp>
     </p:spTree>
     <p:extLst>
       <p:ext uri="{BB962C8B-B14F-4D97-AF65-F5344CB8AC3E}">
@@ -13981,7 +14237,7 @@
                                         <p:tgtEl>
                                           <p:spTgt spid="3">
                                             <p:txEl>
-                                              <p:pRg st="2" end="2"/>
+                                              <p:pRg st="1" end="1"/>
                                             </p:txEl>
                                           </p:spTgt>
                                         </p:tgtEl>
@@ -14030,7 +14286,7 @@
                                         <p:tgtEl>
                                           <p:spTgt spid="3">
                                             <p:txEl>
-                                              <p:pRg st="3" end="3"/>
+                                              <p:pRg st="2" end="2"/>
                                             </p:txEl>
                                           </p:spTgt>
                                         </p:tgtEl>
@@ -14079,7 +14335,7 @@
                                         <p:tgtEl>
                                           <p:spTgt spid="3">
                                             <p:txEl>
-                                              <p:pRg st="4" end="4"/>
+                                              <p:pRg st="3" end="3"/>
                                             </p:txEl>
                                           </p:spTgt>
                                         </p:tgtEl>
@@ -14128,7 +14384,7 @@
                                         <p:tgtEl>
                                           <p:spTgt spid="3">
                                             <p:txEl>
-                                              <p:pRg st="5" end="5"/>
+                                              <p:pRg st="4" end="4"/>
                                             </p:txEl>
                                           </p:spTgt>
                                         </p:tgtEl>
@@ -14177,7 +14433,7 @@
                                         <p:tgtEl>
                                           <p:spTgt spid="3">
                                             <p:txEl>
-                                              <p:pRg st="6" end="6"/>
+                                              <p:pRg st="5" end="5"/>
                                             </p:txEl>
                                           </p:spTgt>
                                         </p:tgtEl>
@@ -14219,6 +14475,55 @@
                                     <p:set>
                                       <p:cBhvr>
                                         <p:cTn id="30" dur="1" fill="hold">
+                                          <p:stCondLst>
+                                            <p:cond delay="0"/>
+                                          </p:stCondLst>
+                                        </p:cTn>
+                                        <p:tgtEl>
+                                          <p:spTgt spid="3">
+                                            <p:txEl>
+                                              <p:pRg st="6" end="6"/>
+                                            </p:txEl>
+                                          </p:spTgt>
+                                        </p:tgtEl>
+                                        <p:attrNameLst>
+                                          <p:attrName>style.visibility</p:attrName>
+                                        </p:attrNameLst>
+                                      </p:cBhvr>
+                                      <p:to>
+                                        <p:strVal val="visible"/>
+                                      </p:to>
+                                    </p:set>
+                                  </p:childTnLst>
+                                </p:cTn>
+                              </p:par>
+                            </p:childTnLst>
+                          </p:cTn>
+                        </p:par>
+                      </p:childTnLst>
+                    </p:cTn>
+                  </p:par>
+                  <p:par>
+                    <p:cTn id="31" fill="hold">
+                      <p:stCondLst>
+                        <p:cond delay="indefinite"/>
+                      </p:stCondLst>
+                      <p:childTnLst>
+                        <p:par>
+                          <p:cTn id="32" fill="hold">
+                            <p:stCondLst>
+                              <p:cond delay="0"/>
+                            </p:stCondLst>
+                            <p:childTnLst>
+                              <p:par>
+                                <p:cTn id="33" presetID="1" presetClass="entr" presetSubtype="0" fill="hold" grpId="0" nodeType="clickEffect">
+                                  <p:stCondLst>
+                                    <p:cond delay="0"/>
+                                  </p:stCondLst>
+                                  <p:childTnLst>
+                                    <p:set>
+                                      <p:cBhvr>
+                                        <p:cTn id="34" dur="1" fill="hold">
                                           <p:stCondLst>
                                             <p:cond delay="0"/>
                                           </p:stCondLst>
@@ -16491,15 +16796,33 @@
                                   </p:childTnLst>
                                 </p:cTn>
                               </p:par>
+                            </p:childTnLst>
+                          </p:cTn>
+                        </p:par>
+                      </p:childTnLst>
+                    </p:cTn>
+                  </p:par>
+                  <p:par>
+                    <p:cTn id="7" fill="hold">
+                      <p:stCondLst>
+                        <p:cond delay="indefinite"/>
+                      </p:stCondLst>
+                      <p:childTnLst>
+                        <p:par>
+                          <p:cTn id="8" fill="hold">
+                            <p:stCondLst>
+                              <p:cond delay="0"/>
+                            </p:stCondLst>
+                            <p:childTnLst>
                               <p:par>
-                                <p:cTn id="7" presetID="1" presetClass="entr" presetSubtype="0" fill="hold" grpId="0" nodeType="withEffect">
+                                <p:cTn id="9" presetID="1" presetClass="entr" presetSubtype="0" fill="hold" grpId="0" nodeType="clickEffect">
                                   <p:stCondLst>
                                     <p:cond delay="0"/>
                                   </p:stCondLst>
                                   <p:childTnLst>
                                     <p:set>
                                       <p:cBhvr>
-                                        <p:cTn id="8" dur="1" fill="hold">
+                                        <p:cTn id="10" dur="1" fill="hold">
                                           <p:stCondLst>
                                             <p:cond delay="0"/>
                                           </p:stCondLst>
@@ -16522,15 +16845,33 @@
                                   </p:childTnLst>
                                 </p:cTn>
                               </p:par>
+                            </p:childTnLst>
+                          </p:cTn>
+                        </p:par>
+                      </p:childTnLst>
+                    </p:cTn>
+                  </p:par>
+                  <p:par>
+                    <p:cTn id="11" fill="hold">
+                      <p:stCondLst>
+                        <p:cond delay="indefinite"/>
+                      </p:stCondLst>
+                      <p:childTnLst>
+                        <p:par>
+                          <p:cTn id="12" fill="hold">
+                            <p:stCondLst>
+                              <p:cond delay="0"/>
+                            </p:stCondLst>
+                            <p:childTnLst>
                               <p:par>
-                                <p:cTn id="9" presetID="1" presetClass="entr" presetSubtype="0" fill="hold" grpId="0" nodeType="withEffect">
+                                <p:cTn id="13" presetID="1" presetClass="entr" presetSubtype="0" fill="hold" grpId="0" nodeType="clickEffect">
                                   <p:stCondLst>
                                     <p:cond delay="0"/>
                                   </p:stCondLst>
                                   <p:childTnLst>
                                     <p:set>
                                       <p:cBhvr>
-                                        <p:cTn id="10" dur="1" fill="hold">
+                                        <p:cTn id="14" dur="1" fill="hold">
                                           <p:stCondLst>
                                             <p:cond delay="0"/>
                                           </p:stCondLst>
@@ -16553,15 +16894,33 @@
                                   </p:childTnLst>
                                 </p:cTn>
                               </p:par>
+                            </p:childTnLst>
+                          </p:cTn>
+                        </p:par>
+                      </p:childTnLst>
+                    </p:cTn>
+                  </p:par>
+                  <p:par>
+                    <p:cTn id="15" fill="hold">
+                      <p:stCondLst>
+                        <p:cond delay="indefinite"/>
+                      </p:stCondLst>
+                      <p:childTnLst>
+                        <p:par>
+                          <p:cTn id="16" fill="hold">
+                            <p:stCondLst>
+                              <p:cond delay="0"/>
+                            </p:stCondLst>
+                            <p:childTnLst>
                               <p:par>
-                                <p:cTn id="11" presetID="1" presetClass="entr" presetSubtype="0" fill="hold" grpId="0" nodeType="withEffect">
+                                <p:cTn id="17" presetID="1" presetClass="entr" presetSubtype="0" fill="hold" grpId="0" nodeType="clickEffect">
                                   <p:stCondLst>
                                     <p:cond delay="0"/>
                                   </p:stCondLst>
                                   <p:childTnLst>
                                     <p:set>
                                       <p:cBhvr>
-                                        <p:cTn id="12" dur="1" fill="hold">
+                                        <p:cTn id="18" dur="1" fill="hold">
                                           <p:stCondLst>
                                             <p:cond delay="0"/>
                                           </p:stCondLst>
@@ -16584,15 +16943,33 @@
                                   </p:childTnLst>
                                 </p:cTn>
                               </p:par>
+                            </p:childTnLst>
+                          </p:cTn>
+                        </p:par>
+                      </p:childTnLst>
+                    </p:cTn>
+                  </p:par>
+                  <p:par>
+                    <p:cTn id="19" fill="hold">
+                      <p:stCondLst>
+                        <p:cond delay="indefinite"/>
+                      </p:stCondLst>
+                      <p:childTnLst>
+                        <p:par>
+                          <p:cTn id="20" fill="hold">
+                            <p:stCondLst>
+                              <p:cond delay="0"/>
+                            </p:stCondLst>
+                            <p:childTnLst>
                               <p:par>
-                                <p:cTn id="13" presetID="1" presetClass="entr" presetSubtype="0" fill="hold" grpId="0" nodeType="withEffect">
+                                <p:cTn id="21" presetID="1" presetClass="entr" presetSubtype="0" fill="hold" grpId="0" nodeType="clickEffect">
                                   <p:stCondLst>
                                     <p:cond delay="0"/>
                                   </p:stCondLst>
                                   <p:childTnLst>
                                     <p:set>
                                       <p:cBhvr>
-                                        <p:cTn id="14" dur="1" fill="hold">
+                                        <p:cTn id="22" dur="1" fill="hold">
                                           <p:stCondLst>
                                             <p:cond delay="0"/>
                                           </p:stCondLst>
@@ -16615,15 +16992,33 @@
                                   </p:childTnLst>
                                 </p:cTn>
                               </p:par>
+                            </p:childTnLst>
+                          </p:cTn>
+                        </p:par>
+                      </p:childTnLst>
+                    </p:cTn>
+                  </p:par>
+                  <p:par>
+                    <p:cTn id="23" fill="hold">
+                      <p:stCondLst>
+                        <p:cond delay="indefinite"/>
+                      </p:stCondLst>
+                      <p:childTnLst>
+                        <p:par>
+                          <p:cTn id="24" fill="hold">
+                            <p:stCondLst>
+                              <p:cond delay="0"/>
+                            </p:stCondLst>
+                            <p:childTnLst>
                               <p:par>
-                                <p:cTn id="15" presetID="1" presetClass="entr" presetSubtype="0" fill="hold" grpId="0" nodeType="withEffect">
+                                <p:cTn id="25" presetID="1" presetClass="entr" presetSubtype="0" fill="hold" grpId="0" nodeType="clickEffect">
                                   <p:stCondLst>
                                     <p:cond delay="0"/>
                                   </p:stCondLst>
                                   <p:childTnLst>
                                     <p:set>
                                       <p:cBhvr>
-                                        <p:cTn id="16" dur="1" fill="hold">
+                                        <p:cTn id="26" dur="1" fill="hold">
                                           <p:stCondLst>
                                             <p:cond delay="0"/>
                                           </p:stCondLst>

</xml_diff>